<commit_message>
Remove chi-square/hour-of-day content from the Canva deck
Mirrors the notebook/report change. The "EDA: Temporal Features" slide's
chi-square table and its "LIMITED / NO SIGNAL" box are replaced with a
real ACF/PACF plot (48 lags) and the ADF stationarity test - both
already-computed, unaffected findings that now fully support the
slide on their own. Also fixed a stray chi-square mention in the
Feature Selection slide's intro line.
</commit_message>
<xml_diff>
--- a/presentation/capstone-btc-volatility-canva.pptx
+++ b/presentation/capstone-btc-volatility-canva.pptx
@@ -4018,7 +4018,7 @@
                 </a:solidFill>
                 <a:latin typeface="Calibri"/>
               </a:rPr>
-              <a:t>all continuous features tested against the target; Chi-Square confirms hour-of-day carries no signal (p = 1.000).</a:t>
+              <a:t>all continuous features tested against the target - the strongest are theoretically motivated, not just statistically convenient.</a:t>
             </a:r>
           </a:p>
         </p:txBody>
@@ -20419,7 +20419,7 @@
                 </a:solidFill>
                 <a:latin typeface="Calibri"/>
               </a:rPr>
-              <a:t>Does when something happens carry any signal about how severe it will be?</a:t>
+              <a:t>Does volatility have memory - and is that memory usable?</a:t>
             </a:r>
           </a:p>
         </p:txBody>
@@ -20475,7 +20475,7 @@
         <p:spPr>
           <a:xfrm>
             <a:off x="502920" y="1965960"/>
-            <a:ext cx="5212080" cy="1920240"/>
+            <a:ext cx="5212080" cy="2148840"/>
           </a:xfrm>
           <a:prstGeom prst="rect">
             <a:avLst/>
@@ -20519,7 +20519,7 @@
         <p:spPr>
           <a:xfrm>
             <a:off x="502920" y="1965960"/>
-            <a:ext cx="45720" cy="1920240"/>
+            <a:ext cx="45720" cy="2148840"/>
           </a:xfrm>
           <a:prstGeom prst="rect">
             <a:avLst/>
@@ -20605,7 +20605,7 @@
         <p:spPr>
           <a:xfrm>
             <a:off x="777240" y="2386584"/>
-            <a:ext cx="4663440" cy="1371600"/>
+            <a:ext cx="4663440" cy="1600200"/>
           </a:xfrm>
           <a:prstGeom prst="rect">
             <a:avLst/>
@@ -20640,266 +20640,14 @@
       </p:sp>
       <p:sp>
         <p:nvSpPr>
-          <p:cNvPr id="11" name="TextBox 10"/>
-          <p:cNvSpPr txBox="1"/>
-          <p:nvPr/>
-        </p:nvSpPr>
-        <p:spPr>
-          <a:xfrm>
-            <a:off x="6035040" y="1554480"/>
-            <a:ext cx="5212080" cy="320040"/>
-          </a:xfrm>
-          <a:prstGeom prst="rect">
-            <a:avLst/>
-          </a:prstGeom>
-          <a:noFill/>
-        </p:spPr>
-        <p:txBody>
-          <a:bodyPr wrap="square" anchor="t" lIns="0" rIns="0" tIns="0" bIns="0">
-            <a:spAutoFit/>
-          </a:bodyPr>
-          <a:lstStyle/>
-          <a:p>
-            <a:pPr algn="l">
-              <a:lnSpc>
-                <a:spcPct val="100000"/>
-              </a:lnSpc>
-              <a:spcAft>
-                <a:spcPts val="0"/>
-              </a:spcAft>
-            </a:pPr>
-            <a:r>
-              <a:rPr sz="1400" b="1" i="0">
-                <a:solidFill>
-                  <a:srgbClr val="FFFFFF"/>
-                </a:solidFill>
-                <a:latin typeface="Calibri"/>
-              </a:rPr>
-              <a:t>Hour-of-Day / Day-of-Week</a:t>
-            </a:r>
-          </a:p>
-        </p:txBody>
-      </p:sp>
-      <p:graphicFrame>
-        <p:nvGraphicFramePr>
-          <p:cNvPr id="12" name="Table 11"/>
-          <p:cNvGraphicFramePr>
-            <a:graphicFrameLocks noGrp="1"/>
-          </p:cNvGraphicFramePr>
-          <p:nvPr/>
-        </p:nvGraphicFramePr>
-        <p:xfrm>
-          <a:off x="6035040" y="1965960"/>
-          <a:ext cx="5212080" cy="1463040"/>
-        </p:xfrm>
-        <a:graphic>
-          <a:graphicData uri="http://schemas.openxmlformats.org/drawingml/2006/table">
-            <a:tbl>
-              <a:tblPr firstRow="0" bandRow="0">
-                <a:tableStyleId>{5C22544A-7EE6-4342-B048-85BDC9FD1C3A}</a:tableStyleId>
-              </a:tblPr>
-              <a:tblGrid>
-                <a:gridCol w="3108960"/>
-                <a:gridCol w="2103120"/>
-              </a:tblGrid>
-              <a:tr h="365760">
-                <a:tc>
-                  <a:txBody>
-                    <a:bodyPr wrap="square"/>
-                    <a:lstStyle/>
-                    <a:p>
-                      <a:r>
-                        <a:rPr sz="1350" b="1">
-                          <a:solidFill>
-                            <a:srgbClr val="FFFFFF"/>
-                          </a:solidFill>
-                          <a:latin typeface="Calibri"/>
-                        </a:rPr>
-                        <a:t>Test</a:t>
-                      </a:r>
-                    </a:p>
-                  </a:txBody>
-                  <a:tcPr marL="109728" marR="109728" marT="36576" marB="36576" anchor="ctr">
-                    <a:solidFill>
-                      <a:srgbClr val="000000"/>
-                    </a:solidFill>
-                  </a:tcPr>
-                </a:tc>
-                <a:tc>
-                  <a:txBody>
-                    <a:bodyPr wrap="square"/>
-                    <a:lstStyle/>
-                    <a:p>
-                      <a:r>
-                        <a:rPr sz="1350" b="1">
-                          <a:solidFill>
-                            <a:srgbClr val="FFFFFF"/>
-                          </a:solidFill>
-                          <a:latin typeface="Calibri"/>
-                        </a:rPr>
-                        <a:t>Result</a:t>
-                      </a:r>
-                    </a:p>
-                  </a:txBody>
-                  <a:tcPr marL="109728" marR="109728" marT="36576" marB="36576" anchor="ctr">
-                    <a:solidFill>
-                      <a:srgbClr val="000000"/>
-                    </a:solidFill>
-                  </a:tcPr>
-                </a:tc>
-              </a:tr>
-              <a:tr h="365760">
-                <a:tc>
-                  <a:txBody>
-                    <a:bodyPr wrap="square"/>
-                    <a:lstStyle/>
-                    <a:p>
-                      <a:r>
-                        <a:rPr sz="1250" b="0">
-                          <a:solidFill>
-                            <a:srgbClr val="A9AFBC"/>
-                          </a:solidFill>
-                          <a:latin typeface="Calibri"/>
-                        </a:rPr>
-                        <a:t>Chi-square statistic</a:t>
-                      </a:r>
-                    </a:p>
-                  </a:txBody>
-                  <a:tcPr marL="109728" marR="109728" marT="36576" marB="36576" anchor="ctr">
-                    <a:solidFill>
-                      <a:srgbClr val="12151C"/>
-                    </a:solidFill>
-                  </a:tcPr>
-                </a:tc>
-                <a:tc>
-                  <a:txBody>
-                    <a:bodyPr wrap="square"/>
-                    <a:lstStyle/>
-                    <a:p>
-                      <a:r>
-                        <a:rPr sz="1250" b="0">
-                          <a:solidFill>
-                            <a:srgbClr val="A9AFBC"/>
-                          </a:solidFill>
-                          <a:latin typeface="Calibri"/>
-                        </a:rPr>
-                        <a:t>2.68</a:t>
-                      </a:r>
-                    </a:p>
-                  </a:txBody>
-                  <a:tcPr marL="109728" marR="109728" marT="36576" marB="36576" anchor="ctr">
-                    <a:solidFill>
-                      <a:srgbClr val="12151C"/>
-                    </a:solidFill>
-                  </a:tcPr>
-                </a:tc>
-              </a:tr>
-              <a:tr h="365760">
-                <a:tc>
-                  <a:txBody>
-                    <a:bodyPr wrap="square"/>
-                    <a:lstStyle/>
-                    <a:p>
-                      <a:r>
-                        <a:rPr sz="1250" b="0">
-                          <a:solidFill>
-                            <a:srgbClr val="A9AFBC"/>
-                          </a:solidFill>
-                          <a:latin typeface="Calibri"/>
-                        </a:rPr>
-                        <a:t>Degrees of freedom</a:t>
-                      </a:r>
-                    </a:p>
-                  </a:txBody>
-                  <a:tcPr marL="109728" marR="109728" marT="36576" marB="36576" anchor="ctr">
-                    <a:solidFill>
-                      <a:srgbClr val="0E1117"/>
-                    </a:solidFill>
-                  </a:tcPr>
-                </a:tc>
-                <a:tc>
-                  <a:txBody>
-                    <a:bodyPr wrap="square"/>
-                    <a:lstStyle/>
-                    <a:p>
-                      <a:r>
-                        <a:rPr sz="1250" b="0">
-                          <a:solidFill>
-                            <a:srgbClr val="A9AFBC"/>
-                          </a:solidFill>
-                          <a:latin typeface="Calibri"/>
-                        </a:rPr>
-                        <a:t>46</a:t>
-                      </a:r>
-                    </a:p>
-                  </a:txBody>
-                  <a:tcPr marL="109728" marR="109728" marT="36576" marB="36576" anchor="ctr">
-                    <a:solidFill>
-                      <a:srgbClr val="0E1117"/>
-                    </a:solidFill>
-                  </a:tcPr>
-                </a:tc>
-              </a:tr>
-              <a:tr h="365760">
-                <a:tc>
-                  <a:txBody>
-                    <a:bodyPr wrap="square"/>
-                    <a:lstStyle/>
-                    <a:p>
-                      <a:r>
-                        <a:rPr sz="1250" b="0">
-                          <a:solidFill>
-                            <a:srgbClr val="A9AFBC"/>
-                          </a:solidFill>
-                          <a:latin typeface="Calibri"/>
-                        </a:rPr>
-                        <a:t>p-value</a:t>
-                      </a:r>
-                    </a:p>
-                  </a:txBody>
-                  <a:tcPr marL="109728" marR="109728" marT="36576" marB="36576" anchor="ctr">
-                    <a:solidFill>
-                      <a:srgbClr val="12151C"/>
-                    </a:solidFill>
-                  </a:tcPr>
-                </a:tc>
-                <a:tc>
-                  <a:txBody>
-                    <a:bodyPr wrap="square"/>
-                    <a:lstStyle/>
-                    <a:p>
-                      <a:r>
-                        <a:rPr sz="1250" b="0">
-                          <a:solidFill>
-                            <a:srgbClr val="A9AFBC"/>
-                          </a:solidFill>
-                          <a:latin typeface="Calibri"/>
-                        </a:rPr>
-                        <a:t>1.000000</a:t>
-                      </a:r>
-                    </a:p>
-                  </a:txBody>
-                  <a:tcPr marL="109728" marR="109728" marT="36576" marB="36576" anchor="ctr">
-                    <a:solidFill>
-                      <a:srgbClr val="12151C"/>
-                    </a:solidFill>
-                  </a:tcPr>
-                </a:tc>
-              </a:tr>
-            </a:tbl>
-          </a:graphicData>
-        </a:graphic>
-      </p:graphicFrame>
-      <p:sp>
-        <p:nvSpPr>
-          <p:cNvPr id="13" name="Rectangle 12"/>
+          <p:cNvPr id="11" name="Rectangle 10"/>
           <p:cNvSpPr/>
           <p:nvPr/>
         </p:nvSpPr>
         <p:spPr>
           <a:xfrm>
-            <a:off x="6035040" y="3520440"/>
-            <a:ext cx="5212080" cy="1417320"/>
+            <a:off x="502920" y="4251960"/>
+            <a:ext cx="5212080" cy="1783080"/>
           </a:xfrm>
           <a:prstGeom prst="rect">
             <a:avLst/>
@@ -20936,20 +20684,20 @@
       </p:sp>
       <p:sp>
         <p:nvSpPr>
-          <p:cNvPr id="14" name="Rectangle 13"/>
+          <p:cNvPr id="12" name="Rectangle 11"/>
           <p:cNvSpPr/>
           <p:nvPr/>
         </p:nvSpPr>
         <p:spPr>
           <a:xfrm>
-            <a:off x="6035040" y="3520440"/>
-            <a:ext cx="45720" cy="1417320"/>
+            <a:off x="502920" y="4251960"/>
+            <a:ext cx="45720" cy="1783080"/>
           </a:xfrm>
           <a:prstGeom prst="rect">
             <a:avLst/>
           </a:prstGeom>
           <a:solidFill>
-            <a:srgbClr val="C4645A"/>
+            <a:srgbClr val="5B7FA8"/>
           </a:solidFill>
           <a:ln>
             <a:noFill/>
@@ -20980,13 +20728,13 @@
       </p:sp>
       <p:sp>
         <p:nvSpPr>
-          <p:cNvPr id="15" name="TextBox 14"/>
-          <p:cNvSpPr txBox="1"/>
-          <p:nvPr/>
-        </p:nvSpPr>
-        <p:spPr>
-          <a:xfrm>
-            <a:off x="6309360" y="3648456"/>
+          <p:cNvPr id="13" name="TextBox 12"/>
+          <p:cNvSpPr txBox="1"/>
+          <p:nvPr/>
+        </p:nvSpPr>
+        <p:spPr>
+          <a:xfrm>
+            <a:off x="777240" y="4379976"/>
             <a:ext cx="4663440" cy="274320"/>
           </a:xfrm>
           <a:prstGeom prst="rect">
@@ -21011,25 +20759,25 @@
             <a:r>
               <a:rPr sz="1250" b="1" i="0">
                 <a:solidFill>
-                  <a:srgbClr val="C4645A"/>
-                </a:solidFill>
-                <a:latin typeface="Calibri"/>
-              </a:rPr>
-              <a:t>LIMITED / NO SIGNAL</a:t>
-            </a:r>
-          </a:p>
-        </p:txBody>
-      </p:sp>
-      <p:sp>
-        <p:nvSpPr>
-          <p:cNvPr id="16" name="TextBox 15"/>
-          <p:cNvSpPr txBox="1"/>
-          <p:nvPr/>
-        </p:nvSpPr>
-        <p:spPr>
-          <a:xfrm>
-            <a:off x="6309360" y="3941064"/>
-            <a:ext cx="4663440" cy="868680"/>
+                  <a:srgbClr val="5B7FA8"/>
+                </a:solidFill>
+                <a:latin typeface="Calibri"/>
+              </a:rPr>
+              <a:t>STATIONARITY CONFIRMED</a:t>
+            </a:r>
+          </a:p>
+        </p:txBody>
+      </p:sp>
+      <p:sp>
+        <p:nvSpPr>
+          <p:cNvPr id="14" name="TextBox 13"/>
+          <p:cNvSpPr txBox="1"/>
+          <p:nvPr/>
+        </p:nvSpPr>
+        <p:spPr>
+          <a:xfrm>
+            <a:off x="777240" y="4672584"/>
+            <a:ext cx="4663440" cy="1234440"/>
           </a:xfrm>
           <a:prstGeom prst="rect">
             <a:avLst/>
@@ -21057,11 +20805,77 @@
                 </a:solidFill>
                 <a:latin typeface="Calibri"/>
               </a:rPr>
-              <a:t>No significant association between hour-of-day and volatility regime (p &gt;= 0.05). Holt-Winters' own seasonal parameter converges to ~0 independently - two different methods agreeing time-of-day isn't real signal here.</a:t>
-            </a:r>
-          </a:p>
-        </p:txBody>
-      </p:sp>
+              <a:t>Augmented Dickey-Fuller test: statistic = -9.24, p &lt; 0.0001. The unit-root null is rejected at essentially any conventional level - volatility_7d is stationary, consistent with the ACF/PACF plots decaying rather than staying persistently high.</a:t>
+            </a:r>
+          </a:p>
+        </p:txBody>
+      </p:sp>
+      <p:sp>
+        <p:nvSpPr>
+          <p:cNvPr id="15" name="TextBox 14"/>
+          <p:cNvSpPr txBox="1"/>
+          <p:nvPr/>
+        </p:nvSpPr>
+        <p:spPr>
+          <a:xfrm>
+            <a:off x="6035040" y="1554480"/>
+            <a:ext cx="5212080" cy="320040"/>
+          </a:xfrm>
+          <a:prstGeom prst="rect">
+            <a:avLst/>
+          </a:prstGeom>
+          <a:noFill/>
+        </p:spPr>
+        <p:txBody>
+          <a:bodyPr wrap="square" anchor="t" lIns="0" rIns="0" tIns="0" bIns="0">
+            <a:spAutoFit/>
+          </a:bodyPr>
+          <a:lstStyle/>
+          <a:p>
+            <a:pPr algn="l">
+              <a:lnSpc>
+                <a:spcPct val="100000"/>
+              </a:lnSpc>
+              <a:spcAft>
+                <a:spcPts val="0"/>
+              </a:spcAft>
+            </a:pPr>
+            <a:r>
+              <a:rPr sz="1400" b="1" i="0">
+                <a:solidFill>
+                  <a:srgbClr val="FFFFFF"/>
+                </a:solidFill>
+                <a:latin typeface="Calibri"/>
+              </a:rPr>
+              <a:t>ACF / PACF (48 Lags)</a:t>
+            </a:r>
+          </a:p>
+        </p:txBody>
+      </p:sp>
+      <p:pic>
+        <p:nvPicPr>
+          <p:cNvPr id="16" name="Picture 15" descr="acf_plot.png"/>
+          <p:cNvPicPr>
+            <a:picLocks noChangeAspect="1"/>
+          </p:cNvPicPr>
+          <p:nvPr/>
+        </p:nvPicPr>
+        <p:blipFill>
+          <a:blip r:embed="rId2"/>
+          <a:stretch>
+            <a:fillRect/>
+          </a:stretch>
+        </p:blipFill>
+        <p:spPr>
+          <a:xfrm>
+            <a:off x="5989320" y="1965960"/>
+            <a:ext cx="5349240" cy="2651760"/>
+          </a:xfrm>
+          <a:prstGeom prst="rect">
+            <a:avLst/>
+          </a:prstGeom>
+        </p:spPr>
+      </p:pic>
       <p:sp>
         <p:nvSpPr>
           <p:cNvPr id="17" name="Rectangle 16"/>
@@ -21070,8 +20884,8 @@
         </p:nvSpPr>
         <p:spPr>
           <a:xfrm>
-            <a:off x="502920" y="5074920"/>
-            <a:ext cx="10744200" cy="960120"/>
+            <a:off x="6035040" y="4892040"/>
+            <a:ext cx="5212080" cy="1143000"/>
           </a:xfrm>
           <a:prstGeom prst="rect">
             <a:avLst/>
@@ -21114,14 +20928,14 @@
         </p:nvSpPr>
         <p:spPr>
           <a:xfrm>
-            <a:off x="502920" y="5074920"/>
-            <a:ext cx="45720" cy="960120"/>
+            <a:off x="6035040" y="4892040"/>
+            <a:ext cx="45720" cy="1143000"/>
           </a:xfrm>
           <a:prstGeom prst="rect">
             <a:avLst/>
           </a:prstGeom>
           <a:solidFill>
-            <a:srgbClr val="5B7FA8"/>
+            <a:srgbClr val="E8C99B"/>
           </a:solidFill>
           <a:ln>
             <a:noFill/>
@@ -21158,8 +20972,8 @@
         </p:nvSpPr>
         <p:spPr>
           <a:xfrm>
-            <a:off x="777240" y="5202936"/>
-            <a:ext cx="10195560" cy="274320"/>
+            <a:off x="6309360" y="5020056"/>
+            <a:ext cx="4663440" cy="274320"/>
           </a:xfrm>
           <a:prstGeom prst="rect">
             <a:avLst/>
@@ -21183,7 +20997,7 @@
             <a:r>
               <a:rPr sz="1250" b="1" i="0">
                 <a:solidFill>
-                  <a:srgbClr val="5B7FA8"/>
+                  <a:srgbClr val="E8C99B"/>
                 </a:solidFill>
                 <a:latin typeface="Calibri"/>
               </a:rPr>
@@ -21200,8 +21014,8 @@
         </p:nvSpPr>
         <p:spPr>
           <a:xfrm>
-            <a:off x="777240" y="5495544"/>
-            <a:ext cx="10195560" cy="411480"/>
+            <a:off x="6309360" y="5312664"/>
+            <a:ext cx="4663440" cy="594360"/>
           </a:xfrm>
           <a:prstGeom prst="rect">
             <a:avLst/>
@@ -21229,7 +21043,7 @@
                 </a:solidFill>
                 <a:latin typeface="Calibri"/>
               </a:rPr>
-              <a:t>Volatility's own recent history carries real signal; the calendar (hour, day-of-week) does not. This is exactly why HAR-RV-X's regressors are all volatility measures, not time-of-day features.</a:t>
+              <a:t>Volatility's own recent history carries real, persistent signal - exactly why HAR-RV-X's regressors are all volatility measures at different time horizons, not calendar features.</a:t>
             </a:r>
           </a:p>
         </p:txBody>

</xml_diff>